<commit_message>
sync pages-a (A/staticrypt) with current content (2026-06-04)
</commit_message>
<xml_diff>
--- a/dl/claude_course_s2.pptx
+++ b/dl/claude_course_s2.pptx
@@ -12303,8 +12303,8 @@
         </p:nvSpPr>
         <p:spPr>
           <a:xfrm>
-            <a:off x="2271121" y="3582352"/>
-            <a:ext cx="1934758" cy="213360"/>
+            <a:off x="1896749" y="3582352"/>
+            <a:ext cx="2683502" cy="213360"/>
           </a:xfrm>
           <a:prstGeom prst="rect">
             <a:avLst/>
@@ -12330,7 +12330,7 @@
                 <a:ea typeface="Microsoft YaHei"/>
                 <a:cs typeface="Arial"/>
               </a:rPr>
-              <a:t>搜索权威信息源 → 存 raw/</a:t>
+              <a:t>搜索权威信息源 → 存 raw_material/</a:t>
             </a:r>
           </a:p>
         </p:txBody>
@@ -16726,8 +16726,8 @@
         </p:nvSpPr>
         <p:spPr>
           <a:xfrm>
-            <a:off x="6555891" y="2525078"/>
-            <a:ext cx="4680918" cy="213360"/>
+            <a:off x="6199346" y="2525078"/>
+            <a:ext cx="5394007" cy="213360"/>
           </a:xfrm>
           <a:prstGeom prst="rect">
             <a:avLst/>
@@ -16753,7 +16753,7 @@
                 <a:ea typeface="Microsoft YaHei"/>
                 <a:cs typeface="Arial"/>
               </a:rPr>
-              <a:t>初始化项目 + CLAUDE.md · 生成 raw/ 骨架 · 搜索 401K 第一条 wiki</a:t>
+              <a:t>初始化项目 + CLAUDE.md · 生成 raw_material/ 骨架 · 搜索 401K 第一条 wiki</a:t>
             </a:r>
           </a:p>
         </p:txBody>
@@ -18597,7 +18597,7 @@
         <p:spPr>
           <a:xfrm>
             <a:off x="6498908" y="2500789"/>
-            <a:ext cx="2853523" cy="259080"/>
+            <a:ext cx="3114223" cy="259080"/>
           </a:xfrm>
           <a:prstGeom prst="rect">
             <a:avLst/>
@@ -18623,7 +18623,7 @@
                 <a:ea typeface="Microsoft YaHei"/>
                 <a:cs typeface="Arial"/>
               </a:rPr>
-              <a:t>/brainstorm → 生成客户问题模板</a:t>
+              <a:t>/brainstorming → 生成客户问题模板</a:t>
             </a:r>
           </a:p>
         </p:txBody>
@@ -36032,8 +36032,8 @@
         </p:nvSpPr>
         <p:spPr>
           <a:xfrm>
-            <a:off x="2723102" y="2344102"/>
-            <a:ext cx="3431095" cy="213360"/>
+            <a:off x="2366558" y="2344102"/>
+            <a:ext cx="4144185" cy="213360"/>
           </a:xfrm>
           <a:prstGeom prst="rect">
             <a:avLst/>
@@ -36059,7 +36059,7 @@
                 <a:ea typeface="Microsoft YaHei"/>
                 <a:cs typeface="Consolas"/>
               </a:rPr>
-              <a:t>raw/ wiki/ output/（output 加进 .gitignore）</a:t>
+              <a:t>raw_material/ wiki/ output/（output 加进 .gitignore）</a:t>
             </a:r>
           </a:p>
         </p:txBody>
@@ -51320,8 +51320,8 @@
         </p:nvSpPr>
         <p:spPr>
           <a:xfrm>
-            <a:off x="2121694" y="3145631"/>
-            <a:ext cx="1014412" cy="228600"/>
+            <a:off x="2006679" y="3145631"/>
+            <a:ext cx="1244441" cy="228600"/>
           </a:xfrm>
           <a:prstGeom prst="rect">
             <a:avLst/>
@@ -51347,7 +51347,7 @@
                 <a:ea typeface="Microsoft YaHei"/>
                 <a:cs typeface="Consolas"/>
               </a:rPr>
-              <a:t>/brainstorm</a:t>
+              <a:t>/brainstorming</a:t>
             </a:r>
           </a:p>
         </p:txBody>

</xml_diff>